<commit_message>
ARQ Clase 2: ADR unificado en 6 secciones, plantilla del entregable en el taller y demo con slide citada
</commit_message>
<xml_diff>
--- a/Arquitectura de Sistemas Computacionales/Clases/Clase 2 - Modelos de servicio IaaS PaaS SaaS/Presentacion.pptx
+++ b/Arquitectura de Sistemas Computacionales/Clases/Clase 2 - Modelos de servicio IaaS PaaS SaaS/Presentacion.pptx
@@ -3657,7 +3657,7 @@
                 </a:solidFill>
                 <a:latin typeface="Calibri"/>
               </a:rPr>
-              <a:t> Paso 2: construya en la pregunta 5 la matriz `Criterio | IaaS | PaaS | SaaS` con las cuatro filas en orden (control, costo cualitativo, operacion, time-to-demo) y maximo 2 lineas por celda; verifique que cada celda nombre una capacidad o una restriccion de SU dominio, y que la fila de operacion no afirme que en PaaS o SaaS usted deja de responder por su propia aplicacion.</a:t>
+              <a:t> Paso 2: construya en la pregunta 5 la matriz «Criterio | IaaS | PaaS | SaaS» con las cuatro filas en orden (control, costo cualitativo, operacion, time-to-demo) y maximo 2 lineas por celda; verifique que cada celda nombre una capacidad o una restriccion de SU dominio, y que la fila de operacion no afirme que en PaaS o SaaS usted deja de responder por su propia aplicacion.</a:t>
             </a:r>
           </a:p>
           <a:p>
@@ -3691,7 +3691,7 @@
                 </a:solidFill>
                 <a:latin typeface="Calibri"/>
               </a:rPr>
-              <a:t> Paso 3: redacte en la pregunta 6 el ADR-001 con titulo, estado con fecha, la decision en UNA sola frase con UN modelo dominante, y exactamente 2 alternativas descartadas con el motivo atado a su dominio; verifique que la seccion de decision no nombre dos modelos, porque en ese caso vale cero.</a:t>
+              <a:t> Paso 3: redacte en la pregunta 6 el ADR-001 con las cinco secciones rotuladas —titulo, estado con fecha, contexto con sus restricciones reales, la decision en UNA sola frase con UN modelo dominante, y exactamente 2 alternativas descartadas con el motivo atado a su dominio—; verifique que la seccion de decision no nombre dos modelos, porque en ese caso vale cero.</a:t>
             </a:r>
           </a:p>
           <a:p>
@@ -3725,7 +3725,7 @@
                 </a:solidFill>
                 <a:latin typeface="Calibri"/>
               </a:rPr>
-              <a:t> Paso 4: escriba en la pregunta 7 las consecuencias en los tres ejes (operacion, costo y aprendizaje), con al menos una positiva y una negativa por eje marcadas con + y -, y verifique que al menos una negativa hable de amarre al proveedor o de perdida de control; guarde y continue, que la actividad se entrega completa al cierre del corte.</a:t>
+              <a:t> Paso 4: escriba en la pregunta 7 la seccion 6 del mismo ADR, las consecuencias en los tres ejes (operacion, costo y aprendizaje), con al menos una positiva y una negativa por eje marcadas con + y -, y verifique que al menos una negativa hable de amarre al proveedor o de perdida de control; guarde y continue, que la actividad se entrega completa al cierre del corte.</a:t>
             </a:r>
           </a:p>
         </p:txBody>
@@ -6364,7 +6364,25 @@
                 </a:solidFill>
                 <a:latin typeface="Calibri"/>
               </a:rPr>
-              <a:t>–   Contexto · Decisión · Alternativas · Consecuencias · Riesgos.</a:t>
+              <a:t>–   </a:t>
+            </a:r>
+            <a:r>
+              <a:rPr sz="1600" b="1" i="0">
+                <a:solidFill>
+                  <a:srgbClr val="333333"/>
+                </a:solidFill>
+                <a:latin typeface="Calibri"/>
+              </a:rPr>
+              <a:t>6 secciones rotuladas</a:t>
+            </a:r>
+            <a:r>
+              <a:rPr sz="1600" b="0" i="0">
+                <a:solidFill>
+                  <a:srgbClr val="333333"/>
+                </a:solidFill>
+                <a:latin typeface="Calibri"/>
+              </a:rPr>
+              <a:t>: Título · Estado · Contexto · Decisión · Alternativas descartadas · Consecuencias.</a:t>
             </a:r>
           </a:p>
           <a:p>
@@ -6380,7 +6398,43 @@
                 </a:solidFill>
                 <a:latin typeface="Calibri"/>
               </a:rPr>
-              <a:t>–   Máximo 1 página. Lenguaje de arquitectura, no marketing.</a:t>
+              <a:t>–   </a:t>
+            </a:r>
+            <a:r>
+              <a:rPr sz="1600" b="1" i="0">
+                <a:solidFill>
+                  <a:srgbClr val="333333"/>
+                </a:solidFill>
+                <a:latin typeface="Calibri"/>
+              </a:rPr>
+              <a:t>Título</a:t>
+            </a:r>
+            <a:r>
+              <a:rPr sz="1600" b="0" i="0">
+                <a:solidFill>
+                  <a:srgbClr val="333333"/>
+                </a:solidFill>
+                <a:latin typeface="Calibri"/>
+              </a:rPr>
+              <a:t>: «ADR-001 Modelo de servicio dominante de CloudLite App».  </a:t>
+            </a:r>
+            <a:r>
+              <a:rPr sz="1600" b="1" i="0">
+                <a:solidFill>
+                  <a:srgbClr val="333333"/>
+                </a:solidFill>
+                <a:latin typeface="Calibri"/>
+              </a:rPr>
+              <a:t>Estado</a:t>
+            </a:r>
+            <a:r>
+              <a:rPr sz="1600" b="0" i="0">
+                <a:solidFill>
+                  <a:srgbClr val="333333"/>
+                </a:solidFill>
+                <a:latin typeface="Calibri"/>
+              </a:rPr>
+              <a:t>: Aceptado + fecha de hoy.</a:t>
             </a:r>
           </a:p>
           <a:p>
@@ -6396,7 +6450,147 @@
                 </a:solidFill>
                 <a:latin typeface="Calibri"/>
               </a:rPr>
-              <a:t>–   Debe citar 2 trade-offs (ej.: control vs velocidad de entrega).</a:t>
+              <a:t>–   </a:t>
+            </a:r>
+            <a:r>
+              <a:rPr sz="1600" b="1" i="0">
+                <a:solidFill>
+                  <a:srgbClr val="333333"/>
+                </a:solidFill>
+                <a:latin typeface="Calibri"/>
+              </a:rPr>
+              <a:t>Contexto</a:t>
+            </a:r>
+            <a:r>
+              <a:rPr sz="1600" b="0" i="0">
+                <a:solidFill>
+                  <a:srgbClr val="333333"/>
+                </a:solidFill>
+                <a:latin typeface="Calibri"/>
+              </a:rPr>
+              <a:t> = las restricciones (quién lo sostiene, cuánto tiempo, qué presupuesto), no el resumen del tema.</a:t>
+            </a:r>
+          </a:p>
+          <a:p>
+            <a:pPr>
+              <a:spcAft>
+                <a:spcPts val="800"/>
+              </a:spcAft>
+            </a:pPr>
+            <a:r>
+              <a:rPr sz="1600" b="0" i="0">
+                <a:solidFill>
+                  <a:srgbClr val="333333"/>
+                </a:solidFill>
+                <a:latin typeface="Calibri"/>
+              </a:rPr>
+              <a:t>–   </a:t>
+            </a:r>
+            <a:r>
+              <a:rPr sz="1600" b="1" i="0">
+                <a:solidFill>
+                  <a:srgbClr val="333333"/>
+                </a:solidFill>
+                <a:latin typeface="Calibri"/>
+              </a:rPr>
+              <a:t>Decisión</a:t>
+            </a:r>
+            <a:r>
+              <a:rPr sz="1600" b="0" i="0">
+                <a:solidFill>
+                  <a:srgbClr val="333333"/>
+                </a:solidFill>
+                <a:latin typeface="Calibri"/>
+              </a:rPr>
+              <a:t>: 1 frase, 1 modelo dominante.  </a:t>
+            </a:r>
+            <a:r>
+              <a:rPr sz="1600" b="1" i="0">
+                <a:solidFill>
+                  <a:srgbClr val="333333"/>
+                </a:solidFill>
+                <a:latin typeface="Calibri"/>
+              </a:rPr>
+              <a:t>Alternativas descartadas</a:t>
+            </a:r>
+            <a:r>
+              <a:rPr sz="1600" b="0" i="0">
+                <a:solidFill>
+                  <a:srgbClr val="333333"/>
+                </a:solidFill>
+                <a:latin typeface="Calibri"/>
+              </a:rPr>
+              <a:t>: exactamente 2, con motivo del dominio.</a:t>
+            </a:r>
+          </a:p>
+          <a:p>
+            <a:pPr>
+              <a:spcAft>
+                <a:spcPts val="800"/>
+              </a:spcAft>
+            </a:pPr>
+            <a:r>
+              <a:rPr sz="1600" b="0" i="0">
+                <a:solidFill>
+                  <a:srgbClr val="333333"/>
+                </a:solidFill>
+                <a:latin typeface="Calibri"/>
+              </a:rPr>
+              <a:t>–   Máximo 1 página. Las 5 primeras secciones son la </a:t>
+            </a:r>
+            <a:r>
+              <a:rPr sz="1600" b="1" i="0">
+                <a:solidFill>
+                  <a:srgbClr val="333333"/>
+                </a:solidFill>
+                <a:latin typeface="Calibri"/>
+              </a:rPr>
+              <a:t>pregunta 6</a:t>
+            </a:r>
+            <a:r>
+              <a:rPr sz="1600" b="0" i="0">
+                <a:solidFill>
+                  <a:srgbClr val="333333"/>
+                </a:solidFill>
+                <a:latin typeface="Calibri"/>
+              </a:rPr>
+              <a:t>; </a:t>
+            </a:r>
+            <a:r>
+              <a:rPr sz="1600" b="1" i="0">
+                <a:solidFill>
+                  <a:srgbClr val="333333"/>
+                </a:solidFill>
+                <a:latin typeface="Calibri"/>
+              </a:rPr>
+              <a:t>Consecuencias</a:t>
+            </a:r>
+            <a:r>
+              <a:rPr sz="1600" b="0" i="0">
+                <a:solidFill>
+                  <a:srgbClr val="333333"/>
+                </a:solidFill>
+                <a:latin typeface="Calibri"/>
+              </a:rPr>
+              <a:t> es la </a:t>
+            </a:r>
+            <a:r>
+              <a:rPr sz="1600" b="1" i="0">
+                <a:solidFill>
+                  <a:srgbClr val="333333"/>
+                </a:solidFill>
+                <a:latin typeface="Calibri"/>
+              </a:rPr>
+              <a:t>pregunta 7</a:t>
+            </a:r>
+            <a:r>
+              <a:rPr sz="1600" b="0" i="0">
+                <a:solidFill>
+                  <a:srgbClr val="333333"/>
+                </a:solidFill>
+                <a:latin typeface="Calibri"/>
+              </a:rPr>
+              <a:t>.</a:t>
             </a:r>
           </a:p>
         </p:txBody>
@@ -6577,7 +6771,7 @@
                 </a:solidFill>
                 <a:latin typeface="Calibri"/>
               </a:rPr>
-              <a:t>ADR-001 — la plantilla completa cabe en una pagina</a:t>
+              <a:t>ADR-001 — las 6 secciones caben en una pagina</a:t>
             </a:r>
           </a:p>
         </p:txBody>
@@ -6736,7 +6930,7 @@
                 </a:solidFill>
                 <a:latin typeface="Calibri"/>
               </a:rPr>
-              <a:t># ADR-001: Modelo de servicio de CloudLite</a:t>
+              <a:t>## 1. Titulo     ADR-001 Modelo de servicio dominante de CloudLite App</a:t>
             </a:r>
           </a:p>
           <a:p>
@@ -6752,7 +6946,7 @@
                 </a:solidFill>
                 <a:latin typeface="Calibri"/>
               </a:rPr>
-              <a:t/>
+              <a:t>## 2. Estado     Aceptado — &lt;fecha de hoy&gt;</a:t>
             </a:r>
           </a:p>
           <a:p>
@@ -6768,7 +6962,7 @@
                 </a:solidFill>
                 <a:latin typeface="Calibri"/>
               </a:rPr>
-              <a:t>## Contexto</a:t>
+              <a:t/>
             </a:r>
           </a:p>
           <a:p>
@@ -6784,7 +6978,7 @@
                 </a:solidFill>
                 <a:latin typeface="Calibri"/>
               </a:rPr>
-              <a:t>MVP academico, un desarrollador (2 o 3 si el docente autorizo equipo), sin presupuesto cloud.</a:t>
+              <a:t>## 3. Contexto                    &lt;- restricciones, no resumen del tema</a:t>
             </a:r>
           </a:p>
           <a:p>
@@ -6800,7 +6994,7 @@
                 </a:solidFill>
                 <a:latin typeface="Calibri"/>
               </a:rPr>
-              <a:t/>
+              <a:t>Lo sostengo yo solo, 12 semanas, sin presupuesto cloud ni tarjeta; demo viva el dia de la sustentacion.</a:t>
             </a:r>
           </a:p>
           <a:p>
@@ -6816,7 +7010,7 @@
                 </a:solidFill>
                 <a:latin typeface="Calibri"/>
               </a:rPr>
-              <a:t>## Decision</a:t>
+              <a:t/>
             </a:r>
           </a:p>
           <a:p>
@@ -6832,7 +7026,7 @@
                 </a:solidFill>
                 <a:latin typeface="Calibri"/>
               </a:rPr>
-              <a:t>PaaS conceptual + contenedores (portable).</a:t>
+              <a:t>## 4. Decision                    &lt;- UNA frase, UN modelo dominante</a:t>
             </a:r>
           </a:p>
           <a:p>
@@ -6848,7 +7042,7 @@
                 </a:solidFill>
                 <a:latin typeface="Calibri"/>
               </a:rPr>
-              <a:t/>
+              <a:t>La aplicacion de CloudLite se despliega sobre PaaS.</a:t>
             </a:r>
           </a:p>
           <a:p>
@@ -6864,7 +7058,7 @@
                 </a:solidFill>
                 <a:latin typeface="Calibri"/>
               </a:rPr>
-              <a:t>## Alternativas descartadas</a:t>
+              <a:t/>
             </a:r>
           </a:p>
           <a:p>
@@ -6880,7 +7074,7 @@
                 </a:solidFill>
                 <a:latin typeface="Calibri"/>
               </a:rPr>
-              <a:t>- IaaS: control total, pero operamos SO y red -&gt; tiempo que no tenemos.</a:t>
+              <a:t>## 5. Alternativas descartadas    &lt;- exactamente 2, con motivo del dominio</a:t>
             </a:r>
           </a:p>
           <a:p>
@@ -6896,7 +7090,7 @@
                 </a:solidFill>
                 <a:latin typeface="Calibri"/>
               </a:rPr>
-              <a:t>- SaaS como nucleo: no personalizable; solo satelite (auth/email).</a:t>
+              <a:t>- IaaS: control total, pero yo opero SO y parches -&gt; tiempo que no tengo.</a:t>
             </a:r>
           </a:p>
           <a:p>
@@ -6912,7 +7106,7 @@
                 </a:solidFill>
                 <a:latin typeface="Calibri"/>
               </a:rPr>
-              <a:t/>
+              <a:t>- SaaS como nucleo: no queda nada que arquitecturar; solo satelite (auth/email).</a:t>
             </a:r>
           </a:p>
           <a:p>
@@ -6928,7 +7122,7 @@
                 </a:solidFill>
                 <a:latin typeface="Calibri"/>
               </a:rPr>
-              <a:t>## Consecuencias</a:t>
+              <a:t/>
             </a:r>
           </a:p>
           <a:p>
@@ -6944,7 +7138,23 @@
                 </a:solidFill>
                 <a:latin typeface="Calibri"/>
               </a:rPr>
-              <a:t>+ Menos operacion.  - Menos control de red.  ~ Portabilidad OK.</a:t>
+              <a:t>## 6. Consecuencias               &lt;- pregunta 7: 3 ejes, cada uno con + y -</a:t>
+            </a:r>
+          </a:p>
+          <a:p>
+            <a:pPr>
+              <a:spcAft>
+                <a:spcPts val="400"/>
+              </a:spcAft>
+            </a:pPr>
+            <a:r>
+              <a:rPr sz="1400" b="0" i="0">
+                <a:solidFill>
+                  <a:srgbClr val="FFFFFF"/>
+                </a:solidFill>
+                <a:latin typeface="Calibri"/>
+              </a:rPr>
+              <a:t>Operacion + / -        Costo + / -        Aprendizaje + / -</a:t>
             </a:r>
           </a:p>
         </p:txBody>
@@ -6979,7 +7189,7 @@
                 </a:solidFill>
                 <a:latin typeface="Calibri"/>
               </a:rPr>
-              <a:t>Si el ADR no nombra un modelo DOMINANTE y 2 descartes con razon, no es un ADR.</a:t>
+              <a:t>Sin Titulo y Estado con fecha no hay ADR que citar en la Clase 15: son 1.5 puntos de la pregunta 6.</a:t>
             </a:r>
           </a:p>
         </p:txBody>

</xml_diff>

<commit_message>
Arquitectura Clase 2: entregable al final, "Taller" deja de nombrarse fijo, mas teoria
Reordena build_pptx (comun a las 15 clases): el bloque "PI CloudLite -
entregable de hoy" (que califica) pasa de ir justo despues de Objetivos a ir
justo antes de la practica, para no anunciar la nota antes de explicar el
concepto. La diapositiva final de practica deja de llamarse "Taller PI" ->
"Manos a la obra": el taller es variable, lo decide el docente clase a clase,
igual que ya se hizo con ExamLab/quiz en el resto de cursos.

Se agrega una diapositiva de teoria que faltaba (Responsabilidad compartida,
vendor lock-in) con contenido que ya estaba en el fundamento del guion pero
nunca se proyectaba.

Verificado con SOLO_CLASES=2: _verificar_mapa pasa, verificar_generico.py sin
fallos, render a PDF confirma el nuevo orden y que la diapositiva nueva no se
desborda.
</commit_message>
<xml_diff>
--- a/Arquitectura de Sistemas Computacionales/Clases/Clase 2 - Modelos de servicio IaaS PaaS SaaS/Presentacion.pptx
+++ b/Arquitectura de Sistemas Computacionales/Clases/Clase 2 - Modelos de servicio IaaS PaaS SaaS/Presentacion.pptx
@@ -18,6 +18,7 @@
     <p:sldId id="266" r:id="rId17"/>
     <p:sldId id="267" r:id="rId18"/>
     <p:sldId id="268" r:id="rId19"/>
+    <p:sldId id="269" r:id="rId20"/>
   </p:sldIdLst>
   <p:sldSz cx="12191695" cy="6858000" type="screen4x3"/>
   <p:notesSz cx="6858000" cy="9144000"/>
@@ -4403,7 +4404,7 @@
                 </a:solidFill>
                 <a:latin typeface="Calibri"/>
               </a:rPr>
-              <a:t>Taller PI (paso a paso)</a:t>
+              <a:t>PI CloudLite — entregable de hoy</a:t>
             </a:r>
           </a:p>
         </p:txBody>
@@ -4436,13 +4437,22 @@
               </a:spcAft>
             </a:pPr>
             <a:r>
+              <a:rPr sz="2000" b="0" i="0">
+                <a:solidFill>
+                  <a:srgbClr val="333333"/>
+                </a:solidFill>
+                <a:latin typeface="Calibri"/>
+              </a:rPr>
+              <a:t>–   </a:t>
+            </a:r>
+            <a:r>
               <a:rPr sz="2000" b="1" i="0">
                 <a:solidFill>
                   <a:srgbClr val="333333"/>
                 </a:solidFill>
                 <a:latin typeface="Calibri"/>
               </a:rPr>
-              <a:t>1.</a:t>
+              <a:t>Entregable:</a:t>
             </a:r>
             <a:r>
               <a:rPr sz="2000" b="0" i="0">
@@ -4451,7 +4461,7 @@
                 </a:solidFill>
                 <a:latin typeface="Calibri"/>
               </a:rPr>
-              <a:t> Paso 1: relea su ficha y su C4 Context de la Clase 1. No cambie de dominio: las preguntas 5 a 7 se califican sobre el mismo sistema, y el ADR que redacte hoy se reutiliza en el informe del PI y en la sustentacion de la Clase 15.</a:t>
+              <a:t> ADR-001: decisión de modelo de servicio + matriz de comparación aplicada al dominio</a:t>
             </a:r>
           </a:p>
           <a:p>
@@ -4467,7 +4477,7 @@
                 </a:solidFill>
                 <a:latin typeface="Calibri"/>
               </a:rPr>
-              <a:t>–   </a:t>
+              <a:t>–   Herramienta: </a:t>
             </a:r>
             <a:r>
               <a:rPr sz="2000" b="1" i="0">
@@ -4476,16 +4486,7 @@
                 </a:solidFill>
                 <a:latin typeface="Calibri"/>
               </a:rPr>
-              <a:t>2.</a:t>
-            </a:r>
-            <a:r>
-              <a:rPr sz="2000" b="0" i="0">
-                <a:solidFill>
-                  <a:srgbClr val="333333"/>
-                </a:solidFill>
-                <a:latin typeface="Calibri"/>
-              </a:rPr>
-              <a:t> Paso 2: construya en la pregunta 5 la matriz «Criterio | IaaS | PaaS | SaaS» con las cuatro filas en orden (control, costo cualitativo, operacion, time-to-demo) y maximo 2 lineas por celda; verifique que cada celda nombre una capacidad o una restriccion de SU dominio, y que la fila de operacion no afirme que en PaaS o SaaS usted deja de responder por su propia aplicacion.</a:t>
+              <a:t>Google Docs · draw.io (opcional)</a:t>
             </a:r>
           </a:p>
           <a:p>
@@ -4501,7 +4502,7 @@
                 </a:solidFill>
                 <a:latin typeface="Calibri"/>
               </a:rPr>
-              <a:t>–   </a:t>
+              <a:t>–   Todo lo que construyan hoy entra al </a:t>
             </a:r>
             <a:r>
               <a:rPr sz="2000" b="1" i="0">
@@ -4510,7 +4511,7 @@
                 </a:solidFill>
                 <a:latin typeface="Calibri"/>
               </a:rPr>
-              <a:t>3.</a:t>
+              <a:t>informe/repo del PI</a:t>
             </a:r>
             <a:r>
               <a:rPr sz="2000" b="0" i="0">
@@ -4519,7 +4520,7 @@
                 </a:solidFill>
                 <a:latin typeface="Calibri"/>
               </a:rPr>
-              <a:t> Paso 3: redacte en la pregunta 6 el ADR-001 con las cinco secciones rotuladas —titulo, estado con fecha, contexto con sus restricciones reales, la decision en UNA sola frase con UN modelo dominante, y exactamente 2 alternativas descartadas con el motivo atado a su dominio—; verifique que la seccion de decision no nombre dos modelos, porque en ese caso vale cero.</a:t>
+              <a:t> (no es lab suelto).</a:t>
             </a:r>
           </a:p>
           <a:p>
@@ -4535,25 +4536,7 @@
                 </a:solidFill>
                 <a:latin typeface="Calibri"/>
               </a:rPr>
-              <a:t>–   </a:t>
-            </a:r>
-            <a:r>
-              <a:rPr sz="2000" b="1" i="0">
-                <a:solidFill>
-                  <a:srgbClr val="333333"/>
-                </a:solidFill>
-                <a:latin typeface="Calibri"/>
-              </a:rPr>
-              <a:t>4.</a:t>
-            </a:r>
-            <a:r>
-              <a:rPr sz="2000" b="0" i="0">
-                <a:solidFill>
-                  <a:srgbClr val="333333"/>
-                </a:solidFill>
-                <a:latin typeface="Calibri"/>
-              </a:rPr>
-              <a:t> Paso 4: escriba en la pregunta 7 la seccion 6 del mismo ADR, las consecuencias en los tres ejes (operacion, costo y aprendizaje), con al menos una positiva y una negativa por eje marcadas con + y -, y verifique que al menos una negativa hable de amarre al proveedor o de perdida de control; guarde y continue, que la actividad se entrega completa al cierre del corte.</a:t>
+              <a:t>–   Individual por defecto · el docente puede autorizar equipos de 2–3; la entrega en la plataforma del curso siempre es individual.</a:t>
             </a:r>
           </a:p>
         </p:txBody>
@@ -4734,109 +4717,21 @@
                 </a:solidFill>
                 <a:latin typeface="Calibri"/>
               </a:rPr>
-              <a:t>Para continuar (PI)</a:t>
-            </a:r>
-          </a:p>
-        </p:txBody>
-      </p:sp>
-      <p:sp>
-        <p:nvSpPr>
-          <p:cNvPr id="5" name="Rounded Rectangle 4"/>
-          <p:cNvSpPr/>
-          <p:nvPr/>
-        </p:nvSpPr>
-        <p:spPr>
-          <a:xfrm>
-            <a:off x="457200" y="1261872"/>
-            <a:ext cx="11277295" cy="1051560"/>
-          </a:xfrm>
-          <a:prstGeom prst="roundRect">
-            <a:avLst>
-              <a:gd name="adj" fmla="val 12000"/>
-            </a:avLst>
-          </a:prstGeom>
-          <a:solidFill>
-            <a:srgbClr val="E8F4FA"/>
-          </a:solidFill>
-          <a:ln>
-            <a:noFill/>
-          </a:ln>
-        </p:spPr>
-        <p:style>
-          <a:lnRef idx="1">
-            <a:schemeClr val="accent1"/>
-          </a:lnRef>
-          <a:fillRef idx="3">
-            <a:schemeClr val="accent1"/>
-          </a:fillRef>
-          <a:effectRef idx="2">
-            <a:schemeClr val="accent1"/>
-          </a:effectRef>
-          <a:fontRef idx="minor">
-            <a:schemeClr val="lt1"/>
-          </a:fontRef>
-        </p:style>
-        <p:txBody>
-          <a:bodyPr rtlCol="0" anchor="ctr"/>
-          <a:lstStyle/>
-          <a:p>
-            <a:pPr algn="ctr"/>
-          </a:p>
-        </p:txBody>
-      </p:sp>
-      <p:sp>
-        <p:nvSpPr>
-          <p:cNvPr id="6" name="Rectangle 5"/>
-          <p:cNvSpPr/>
-          <p:nvPr/>
-        </p:nvSpPr>
-        <p:spPr>
-          <a:xfrm>
-            <a:off x="457200" y="1261872"/>
-            <a:ext cx="128016" cy="1051560"/>
-          </a:xfrm>
-          <a:prstGeom prst="rect">
-            <a:avLst/>
-          </a:prstGeom>
-          <a:solidFill>
-            <a:srgbClr val="269CCB"/>
-          </a:solidFill>
-          <a:ln>
-            <a:noFill/>
-          </a:ln>
-        </p:spPr>
-        <p:style>
-          <a:lnRef idx="1">
-            <a:schemeClr val="accent1"/>
-          </a:lnRef>
-          <a:fillRef idx="3">
-            <a:schemeClr val="accent1"/>
-          </a:fillRef>
-          <a:effectRef idx="2">
-            <a:schemeClr val="accent1"/>
-          </a:effectRef>
-          <a:fontRef idx="minor">
-            <a:schemeClr val="lt1"/>
-          </a:fontRef>
-        </p:style>
-        <p:txBody>
-          <a:bodyPr rtlCol="0" anchor="ctr"/>
-          <a:lstStyle/>
-          <a:p>
-            <a:pPr algn="ctr"/>
-          </a:p>
-        </p:txBody>
-      </p:sp>
-      <p:sp>
-        <p:nvSpPr>
-          <p:cNvPr id="7" name="TextBox 6"/>
+              <a:t>Manos a la obra (paso a paso)</a:t>
+            </a:r>
+          </a:p>
+        </p:txBody>
+      </p:sp>
+      <p:sp>
+        <p:nvSpPr>
+          <p:cNvPr id="5" name="TextBox 4"/>
           <p:cNvSpPr txBox="1"/>
           <p:nvPr/>
         </p:nvSpPr>
         <p:spPr>
           <a:xfrm>
-            <a:off x="777240" y="1399031"/>
-            <a:ext cx="10774375" cy="822959"/>
+            <a:off x="457200" y="1170432"/>
+            <a:ext cx="11277295" cy="5230368"/>
           </a:xfrm>
           <a:prstGeom prst="rect">
             <a:avLst/>
@@ -4849,313 +4744,137 @@
           </a:bodyPr>
           <a:lstStyle/>
           <a:p>
-            <a:r>
-              <a:rPr sz="1200" b="1" i="0">
-                <a:solidFill>
-                  <a:srgbClr val="269CCB"/>
-                </a:solidFill>
-                <a:latin typeface="Calibri"/>
-              </a:rPr>
-              <a:t>Info</a:t>
-            </a:r>
-          </a:p>
-          <a:p>
             <a:pPr>
-              <a:spcBef>
-                <a:spcPts val="400"/>
-              </a:spcBef>
+              <a:spcAft>
+                <a:spcPts val="800"/>
+              </a:spcAft>
             </a:pPr>
             <a:r>
-              <a:rPr sz="1400" b="0" i="0">
-                <a:solidFill>
-                  <a:srgbClr val="333333"/>
-                </a:solidFill>
-                <a:latin typeface="Calibri"/>
-              </a:rPr>
-              <a:t>Entregable: ADR-001: decisión de modelo de servicio + matriz de comparación aplicada al dominio</a:t>
-            </a:r>
-          </a:p>
-        </p:txBody>
-      </p:sp>
-      <p:sp>
-        <p:nvSpPr>
-          <p:cNvPr id="8" name="Rounded Rectangle 7"/>
-          <p:cNvSpPr/>
-          <p:nvPr/>
-        </p:nvSpPr>
-        <p:spPr>
-          <a:xfrm>
-            <a:off x="457200" y="2478024"/>
-            <a:ext cx="11277295" cy="1051560"/>
-          </a:xfrm>
-          <a:prstGeom prst="roundRect">
-            <a:avLst>
-              <a:gd name="adj" fmla="val 12000"/>
-            </a:avLst>
-          </a:prstGeom>
-          <a:solidFill>
-            <a:srgbClr val="FFF8E1"/>
-          </a:solidFill>
-          <a:ln>
-            <a:noFill/>
-          </a:ln>
-        </p:spPr>
-        <p:style>
-          <a:lnRef idx="1">
-            <a:schemeClr val="accent1"/>
-          </a:lnRef>
-          <a:fillRef idx="3">
-            <a:schemeClr val="accent1"/>
-          </a:fillRef>
-          <a:effectRef idx="2">
-            <a:schemeClr val="accent1"/>
-          </a:effectRef>
-          <a:fontRef idx="minor">
-            <a:schemeClr val="lt1"/>
-          </a:fontRef>
-        </p:style>
-        <p:txBody>
-          <a:bodyPr rtlCol="0" anchor="ctr"/>
-          <a:lstStyle/>
-          <a:p>
-            <a:pPr algn="ctr"/>
-          </a:p>
-        </p:txBody>
-      </p:sp>
-      <p:sp>
-        <p:nvSpPr>
-          <p:cNvPr id="9" name="Rectangle 8"/>
-          <p:cNvSpPr/>
-          <p:nvPr/>
-        </p:nvSpPr>
-        <p:spPr>
-          <a:xfrm>
-            <a:off x="457200" y="2478024"/>
-            <a:ext cx="128016" cy="1051560"/>
-          </a:xfrm>
-          <a:prstGeom prst="rect">
-            <a:avLst/>
-          </a:prstGeom>
-          <a:solidFill>
-            <a:srgbClr val="FFD000"/>
-          </a:solidFill>
-          <a:ln>
-            <a:noFill/>
-          </a:ln>
-        </p:spPr>
-        <p:style>
-          <a:lnRef idx="1">
-            <a:schemeClr val="accent1"/>
-          </a:lnRef>
-          <a:fillRef idx="3">
-            <a:schemeClr val="accent1"/>
-          </a:fillRef>
-          <a:effectRef idx="2">
-            <a:schemeClr val="accent1"/>
-          </a:effectRef>
-          <a:fontRef idx="minor">
-            <a:schemeClr val="lt1"/>
-          </a:fontRef>
-        </p:style>
-        <p:txBody>
-          <a:bodyPr rtlCol="0" anchor="ctr"/>
-          <a:lstStyle/>
-          <a:p>
-            <a:pPr algn="ctr"/>
-          </a:p>
-        </p:txBody>
-      </p:sp>
-      <p:sp>
-        <p:nvSpPr>
-          <p:cNvPr id="10" name="TextBox 9"/>
-          <p:cNvSpPr txBox="1"/>
-          <p:nvPr/>
-        </p:nvSpPr>
-        <p:spPr>
-          <a:xfrm>
-            <a:off x="777240" y="2615184"/>
-            <a:ext cx="10774375" cy="822959"/>
-          </a:xfrm>
-          <a:prstGeom prst="rect">
-            <a:avLst/>
-          </a:prstGeom>
-          <a:noFill/>
-        </p:spPr>
-        <p:txBody>
-          <a:bodyPr wrap="square">
-            <a:spAutoFit/>
-          </a:bodyPr>
-          <a:lstStyle/>
-          <a:p>
-            <a:r>
-              <a:rPr sz="1200" b="1" i="0">
-                <a:solidFill>
-                  <a:srgbClr val="FFD000"/>
-                </a:solidFill>
-                <a:latin typeface="Calibri"/>
-              </a:rPr>
-              <a:t>Aclaración</a:t>
+              <a:rPr sz="2000" b="1" i="0">
+                <a:solidFill>
+                  <a:srgbClr val="333333"/>
+                </a:solidFill>
+                <a:latin typeface="Calibri"/>
+              </a:rPr>
+              <a:t>1.</a:t>
+            </a:r>
+            <a:r>
+              <a:rPr sz="2000" b="0" i="0">
+                <a:solidFill>
+                  <a:srgbClr val="333333"/>
+                </a:solidFill>
+                <a:latin typeface="Calibri"/>
+              </a:rPr>
+              <a:t> Paso 1: relea su ficha y su C4 Context de la Clase 1. No cambie de dominio: las preguntas 5 a 7 se califican sobre el mismo sistema, y el ADR que redacte hoy se reutiliza en el informe del PI y en la sustentacion de la Clase 15.</a:t>
             </a:r>
           </a:p>
           <a:p>
             <a:pPr>
-              <a:spcBef>
-                <a:spcPts val="400"/>
-              </a:spcBef>
+              <a:spcAft>
+                <a:spcPts val="800"/>
+              </a:spcAft>
             </a:pPr>
             <a:r>
-              <a:rPr sz="1400" b="0" i="0">
-                <a:solidFill>
-                  <a:srgbClr val="333333"/>
-                </a:solidFill>
-                <a:latin typeface="Calibri"/>
-              </a:rPr>
-              <a:t>Subir evidencias al paquete CloudLite (Drive/repo) y a la plataforma del curso en la fecha que indique el docente.</a:t>
-            </a:r>
-          </a:p>
-        </p:txBody>
-      </p:sp>
-      <p:sp>
-        <p:nvSpPr>
-          <p:cNvPr id="11" name="Rounded Rectangle 10"/>
-          <p:cNvSpPr/>
-          <p:nvPr/>
-        </p:nvSpPr>
-        <p:spPr>
-          <a:xfrm>
-            <a:off x="457200" y="3694176"/>
-            <a:ext cx="11277295" cy="1051560"/>
-          </a:xfrm>
-          <a:prstGeom prst="roundRect">
-            <a:avLst>
-              <a:gd name="adj" fmla="val 12000"/>
-            </a:avLst>
-          </a:prstGeom>
-          <a:solidFill>
-            <a:srgbClr val="FBE4E4"/>
-          </a:solidFill>
-          <a:ln>
-            <a:noFill/>
-          </a:ln>
-        </p:spPr>
-        <p:style>
-          <a:lnRef idx="1">
-            <a:schemeClr val="accent1"/>
-          </a:lnRef>
-          <a:fillRef idx="3">
-            <a:schemeClr val="accent1"/>
-          </a:fillRef>
-          <a:effectRef idx="2">
-            <a:schemeClr val="accent1"/>
-          </a:effectRef>
-          <a:fontRef idx="minor">
-            <a:schemeClr val="lt1"/>
-          </a:fontRef>
-        </p:style>
-        <p:txBody>
-          <a:bodyPr rtlCol="0" anchor="ctr"/>
-          <a:lstStyle/>
-          <a:p>
-            <a:pPr algn="ctr"/>
-          </a:p>
-        </p:txBody>
-      </p:sp>
-      <p:sp>
-        <p:nvSpPr>
-          <p:cNvPr id="12" name="Rectangle 11"/>
-          <p:cNvSpPr/>
-          <p:nvPr/>
-        </p:nvSpPr>
-        <p:spPr>
-          <a:xfrm>
-            <a:off x="457200" y="3694176"/>
-            <a:ext cx="128016" cy="1051560"/>
-          </a:xfrm>
-          <a:prstGeom prst="rect">
-            <a:avLst/>
-          </a:prstGeom>
-          <a:solidFill>
-            <a:srgbClr val="A02030"/>
-          </a:solidFill>
-          <a:ln>
-            <a:noFill/>
-          </a:ln>
-        </p:spPr>
-        <p:style>
-          <a:lnRef idx="1">
-            <a:schemeClr val="accent1"/>
-          </a:lnRef>
-          <a:fillRef idx="3">
-            <a:schemeClr val="accent1"/>
-          </a:fillRef>
-          <a:effectRef idx="2">
-            <a:schemeClr val="accent1"/>
-          </a:effectRef>
-          <a:fontRef idx="minor">
-            <a:schemeClr val="lt1"/>
-          </a:fontRef>
-        </p:style>
-        <p:txBody>
-          <a:bodyPr rtlCol="0" anchor="ctr"/>
-          <a:lstStyle/>
-          <a:p>
-            <a:pPr algn="ctr"/>
-          </a:p>
-        </p:txBody>
-      </p:sp>
-      <p:sp>
-        <p:nvSpPr>
-          <p:cNvPr id="13" name="TextBox 12"/>
-          <p:cNvSpPr txBox="1"/>
-          <p:nvPr/>
-        </p:nvSpPr>
-        <p:spPr>
-          <a:xfrm>
-            <a:off x="777240" y="3831336"/>
-            <a:ext cx="10774375" cy="822959"/>
-          </a:xfrm>
-          <a:prstGeom prst="rect">
-            <a:avLst/>
-          </a:prstGeom>
-          <a:noFill/>
-        </p:spPr>
-        <p:txBody>
-          <a:bodyPr wrap="square">
-            <a:spAutoFit/>
-          </a:bodyPr>
-          <a:lstStyle/>
-          <a:p>
-            <a:r>
-              <a:rPr sz="1200" b="1" i="0">
-                <a:solidFill>
-                  <a:srgbClr val="A02030"/>
-                </a:solidFill>
-                <a:latin typeface="Calibri"/>
-              </a:rPr>
-              <a:t>Atención</a:t>
+              <a:rPr sz="2000" b="0" i="0">
+                <a:solidFill>
+                  <a:srgbClr val="333333"/>
+                </a:solidFill>
+                <a:latin typeface="Calibri"/>
+              </a:rPr>
+              <a:t>–   </a:t>
+            </a:r>
+            <a:r>
+              <a:rPr sz="2000" b="1" i="0">
+                <a:solidFill>
+                  <a:srgbClr val="333333"/>
+                </a:solidFill>
+                <a:latin typeface="Calibri"/>
+              </a:rPr>
+              <a:t>2.</a:t>
+            </a:r>
+            <a:r>
+              <a:rPr sz="2000" b="0" i="0">
+                <a:solidFill>
+                  <a:srgbClr val="333333"/>
+                </a:solidFill>
+                <a:latin typeface="Calibri"/>
+              </a:rPr>
+              <a:t> Paso 2: construya en la pregunta 5 la matriz «Criterio | IaaS | PaaS | SaaS» con las cuatro filas en orden (control, costo cualitativo, operacion, time-to-demo) y maximo 2 lineas por celda; verifique que cada celda nombre una capacidad o una restriccion de SU dominio, y que la fila de operacion no afirme que en PaaS o SaaS usted deja de responder por su propia aplicacion.</a:t>
             </a:r>
           </a:p>
           <a:p>
             <a:pPr>
-              <a:spcBef>
-                <a:spcPts val="400"/>
-              </a:spcBef>
+              <a:spcAft>
+                <a:spcPts val="800"/>
+              </a:spcAft>
             </a:pPr>
             <a:r>
-              <a:rPr sz="1400" b="0" i="0">
-                <a:solidFill>
-                  <a:srgbClr val="333333"/>
-                </a:solidFill>
-                <a:latin typeface="Calibri"/>
-              </a:rPr>
-              <a:t>Sin cloud de pago ni instalaciones obligatorias de hipervisores/Docker Desktop.</a:t>
-            </a:r>
-          </a:p>
-        </p:txBody>
-      </p:sp>
-      <p:sp>
-        <p:nvSpPr>
-          <p:cNvPr id="14" name="TextBox 13"/>
+              <a:rPr sz="2000" b="0" i="0">
+                <a:solidFill>
+                  <a:srgbClr val="333333"/>
+                </a:solidFill>
+                <a:latin typeface="Calibri"/>
+              </a:rPr>
+              <a:t>–   </a:t>
+            </a:r>
+            <a:r>
+              <a:rPr sz="2000" b="1" i="0">
+                <a:solidFill>
+                  <a:srgbClr val="333333"/>
+                </a:solidFill>
+                <a:latin typeface="Calibri"/>
+              </a:rPr>
+              <a:t>3.</a:t>
+            </a:r>
+            <a:r>
+              <a:rPr sz="2000" b="0" i="0">
+                <a:solidFill>
+                  <a:srgbClr val="333333"/>
+                </a:solidFill>
+                <a:latin typeface="Calibri"/>
+              </a:rPr>
+              <a:t> Paso 3: redacte en la pregunta 6 el ADR-001 con las cinco secciones rotuladas —titulo, estado con fecha, contexto con sus restricciones reales, la decision en UNA sola frase con UN modelo dominante, y exactamente 2 alternativas descartadas con el motivo atado a su dominio—; verifique que la seccion de decision no nombre dos modelos, porque en ese caso vale cero.</a:t>
+            </a:r>
+          </a:p>
+          <a:p>
+            <a:pPr>
+              <a:spcAft>
+                <a:spcPts val="800"/>
+              </a:spcAft>
+            </a:pPr>
+            <a:r>
+              <a:rPr sz="2000" b="0" i="0">
+                <a:solidFill>
+                  <a:srgbClr val="333333"/>
+                </a:solidFill>
+                <a:latin typeface="Calibri"/>
+              </a:rPr>
+              <a:t>–   </a:t>
+            </a:r>
+            <a:r>
+              <a:rPr sz="2000" b="1" i="0">
+                <a:solidFill>
+                  <a:srgbClr val="333333"/>
+                </a:solidFill>
+                <a:latin typeface="Calibri"/>
+              </a:rPr>
+              <a:t>4.</a:t>
+            </a:r>
+            <a:r>
+              <a:rPr sz="2000" b="0" i="0">
+                <a:solidFill>
+                  <a:srgbClr val="333333"/>
+                </a:solidFill>
+                <a:latin typeface="Calibri"/>
+              </a:rPr>
+              <a:t> Paso 4: escriba en la pregunta 7 la seccion 6 del mismo ADR, las consecuencias en los tres ejes (operacion, costo y aprendizaje), con al menos una positiva y una negativa por eje marcadas con + y -, y verifique que al menos una negativa hable de amarre al proveedor o de perdida de control; guarde y continue, que la actividad se entrega completa al cierre del corte.</a:t>
+            </a:r>
+          </a:p>
+        </p:txBody>
+      </p:sp>
+      <p:sp>
+        <p:nvSpPr>
+          <p:cNvPr id="6" name="TextBox 5"/>
           <p:cNvSpPr txBox="1"/>
           <p:nvPr/>
         </p:nvSpPr>
@@ -5223,6 +4942,601 @@
         <p:spPr>
           <a:xfrm>
             <a:off x="0" y="0"/>
+            <a:ext cx="12191695" cy="960120"/>
+          </a:xfrm>
+          <a:prstGeom prst="rect">
+            <a:avLst/>
+          </a:prstGeom>
+          <a:solidFill>
+            <a:srgbClr val="095292"/>
+          </a:solidFill>
+          <a:ln>
+            <a:noFill/>
+          </a:ln>
+        </p:spPr>
+        <p:style>
+          <a:lnRef idx="1">
+            <a:schemeClr val="accent1"/>
+          </a:lnRef>
+          <a:fillRef idx="3">
+            <a:schemeClr val="accent1"/>
+          </a:fillRef>
+          <a:effectRef idx="2">
+            <a:schemeClr val="accent1"/>
+          </a:effectRef>
+          <a:fontRef idx="minor">
+            <a:schemeClr val="lt1"/>
+          </a:fontRef>
+        </p:style>
+        <p:txBody>
+          <a:bodyPr rtlCol="0" anchor="ctr"/>
+          <a:lstStyle/>
+          <a:p>
+            <a:pPr algn="ctr"/>
+          </a:p>
+        </p:txBody>
+      </p:sp>
+      <p:sp>
+        <p:nvSpPr>
+          <p:cNvPr id="3" name="Rectangle 2"/>
+          <p:cNvSpPr/>
+          <p:nvPr/>
+        </p:nvSpPr>
+        <p:spPr>
+          <a:xfrm>
+            <a:off x="0" y="960120"/>
+            <a:ext cx="12191695" cy="41148"/>
+          </a:xfrm>
+          <a:prstGeom prst="rect">
+            <a:avLst/>
+          </a:prstGeom>
+          <a:solidFill>
+            <a:srgbClr val="FFD000"/>
+          </a:solidFill>
+          <a:ln>
+            <a:noFill/>
+          </a:ln>
+        </p:spPr>
+        <p:style>
+          <a:lnRef idx="1">
+            <a:schemeClr val="accent1"/>
+          </a:lnRef>
+          <a:fillRef idx="3">
+            <a:schemeClr val="accent1"/>
+          </a:fillRef>
+          <a:effectRef idx="2">
+            <a:schemeClr val="accent1"/>
+          </a:effectRef>
+          <a:fontRef idx="minor">
+            <a:schemeClr val="lt1"/>
+          </a:fontRef>
+        </p:style>
+        <p:txBody>
+          <a:bodyPr rtlCol="0" anchor="ctr"/>
+          <a:lstStyle/>
+          <a:p>
+            <a:pPr algn="ctr"/>
+          </a:p>
+        </p:txBody>
+      </p:sp>
+      <p:sp>
+        <p:nvSpPr>
+          <p:cNvPr id="4" name="TextBox 3"/>
+          <p:cNvSpPr txBox="1"/>
+          <p:nvPr/>
+        </p:nvSpPr>
+        <p:spPr>
+          <a:xfrm>
+            <a:off x="457200" y="164592"/>
+            <a:ext cx="11277295" cy="502920"/>
+          </a:xfrm>
+          <a:prstGeom prst="rect">
+            <a:avLst/>
+          </a:prstGeom>
+          <a:noFill/>
+        </p:spPr>
+        <p:txBody>
+          <a:bodyPr wrap="square">
+            <a:spAutoFit/>
+          </a:bodyPr>
+          <a:lstStyle/>
+          <a:p>
+            <a:r>
+              <a:rPr sz="2600" b="1" i="0">
+                <a:solidFill>
+                  <a:srgbClr val="FFFFFF"/>
+                </a:solidFill>
+                <a:latin typeface="Calibri"/>
+              </a:rPr>
+              <a:t>Para continuar (PI)</a:t>
+            </a:r>
+          </a:p>
+        </p:txBody>
+      </p:sp>
+      <p:sp>
+        <p:nvSpPr>
+          <p:cNvPr id="5" name="Rounded Rectangle 4"/>
+          <p:cNvSpPr/>
+          <p:nvPr/>
+        </p:nvSpPr>
+        <p:spPr>
+          <a:xfrm>
+            <a:off x="457200" y="1261872"/>
+            <a:ext cx="11277295" cy="1051560"/>
+          </a:xfrm>
+          <a:prstGeom prst="roundRect">
+            <a:avLst>
+              <a:gd name="adj" fmla="val 12000"/>
+            </a:avLst>
+          </a:prstGeom>
+          <a:solidFill>
+            <a:srgbClr val="E8F4FA"/>
+          </a:solidFill>
+          <a:ln>
+            <a:noFill/>
+          </a:ln>
+        </p:spPr>
+        <p:style>
+          <a:lnRef idx="1">
+            <a:schemeClr val="accent1"/>
+          </a:lnRef>
+          <a:fillRef idx="3">
+            <a:schemeClr val="accent1"/>
+          </a:fillRef>
+          <a:effectRef idx="2">
+            <a:schemeClr val="accent1"/>
+          </a:effectRef>
+          <a:fontRef idx="minor">
+            <a:schemeClr val="lt1"/>
+          </a:fontRef>
+        </p:style>
+        <p:txBody>
+          <a:bodyPr rtlCol="0" anchor="ctr"/>
+          <a:lstStyle/>
+          <a:p>
+            <a:pPr algn="ctr"/>
+          </a:p>
+        </p:txBody>
+      </p:sp>
+      <p:sp>
+        <p:nvSpPr>
+          <p:cNvPr id="6" name="Rectangle 5"/>
+          <p:cNvSpPr/>
+          <p:nvPr/>
+        </p:nvSpPr>
+        <p:spPr>
+          <a:xfrm>
+            <a:off x="457200" y="1261872"/>
+            <a:ext cx="128016" cy="1051560"/>
+          </a:xfrm>
+          <a:prstGeom prst="rect">
+            <a:avLst/>
+          </a:prstGeom>
+          <a:solidFill>
+            <a:srgbClr val="269CCB"/>
+          </a:solidFill>
+          <a:ln>
+            <a:noFill/>
+          </a:ln>
+        </p:spPr>
+        <p:style>
+          <a:lnRef idx="1">
+            <a:schemeClr val="accent1"/>
+          </a:lnRef>
+          <a:fillRef idx="3">
+            <a:schemeClr val="accent1"/>
+          </a:fillRef>
+          <a:effectRef idx="2">
+            <a:schemeClr val="accent1"/>
+          </a:effectRef>
+          <a:fontRef idx="minor">
+            <a:schemeClr val="lt1"/>
+          </a:fontRef>
+        </p:style>
+        <p:txBody>
+          <a:bodyPr rtlCol="0" anchor="ctr"/>
+          <a:lstStyle/>
+          <a:p>
+            <a:pPr algn="ctr"/>
+          </a:p>
+        </p:txBody>
+      </p:sp>
+      <p:sp>
+        <p:nvSpPr>
+          <p:cNvPr id="7" name="TextBox 6"/>
+          <p:cNvSpPr txBox="1"/>
+          <p:nvPr/>
+        </p:nvSpPr>
+        <p:spPr>
+          <a:xfrm>
+            <a:off x="777240" y="1399031"/>
+            <a:ext cx="10774375" cy="822959"/>
+          </a:xfrm>
+          <a:prstGeom prst="rect">
+            <a:avLst/>
+          </a:prstGeom>
+          <a:noFill/>
+        </p:spPr>
+        <p:txBody>
+          <a:bodyPr wrap="square">
+            <a:spAutoFit/>
+          </a:bodyPr>
+          <a:lstStyle/>
+          <a:p>
+            <a:r>
+              <a:rPr sz="1200" b="1" i="0">
+                <a:solidFill>
+                  <a:srgbClr val="269CCB"/>
+                </a:solidFill>
+                <a:latin typeface="Calibri"/>
+              </a:rPr>
+              <a:t>Info</a:t>
+            </a:r>
+          </a:p>
+          <a:p>
+            <a:pPr>
+              <a:spcBef>
+                <a:spcPts val="400"/>
+              </a:spcBef>
+            </a:pPr>
+            <a:r>
+              <a:rPr sz="1400" b="0" i="0">
+                <a:solidFill>
+                  <a:srgbClr val="333333"/>
+                </a:solidFill>
+                <a:latin typeface="Calibri"/>
+              </a:rPr>
+              <a:t>Entregable: ADR-001: decisión de modelo de servicio + matriz de comparación aplicada al dominio</a:t>
+            </a:r>
+          </a:p>
+        </p:txBody>
+      </p:sp>
+      <p:sp>
+        <p:nvSpPr>
+          <p:cNvPr id="8" name="Rounded Rectangle 7"/>
+          <p:cNvSpPr/>
+          <p:nvPr/>
+        </p:nvSpPr>
+        <p:spPr>
+          <a:xfrm>
+            <a:off x="457200" y="2478024"/>
+            <a:ext cx="11277295" cy="1051560"/>
+          </a:xfrm>
+          <a:prstGeom prst="roundRect">
+            <a:avLst>
+              <a:gd name="adj" fmla="val 12000"/>
+            </a:avLst>
+          </a:prstGeom>
+          <a:solidFill>
+            <a:srgbClr val="FFF8E1"/>
+          </a:solidFill>
+          <a:ln>
+            <a:noFill/>
+          </a:ln>
+        </p:spPr>
+        <p:style>
+          <a:lnRef idx="1">
+            <a:schemeClr val="accent1"/>
+          </a:lnRef>
+          <a:fillRef idx="3">
+            <a:schemeClr val="accent1"/>
+          </a:fillRef>
+          <a:effectRef idx="2">
+            <a:schemeClr val="accent1"/>
+          </a:effectRef>
+          <a:fontRef idx="minor">
+            <a:schemeClr val="lt1"/>
+          </a:fontRef>
+        </p:style>
+        <p:txBody>
+          <a:bodyPr rtlCol="0" anchor="ctr"/>
+          <a:lstStyle/>
+          <a:p>
+            <a:pPr algn="ctr"/>
+          </a:p>
+        </p:txBody>
+      </p:sp>
+      <p:sp>
+        <p:nvSpPr>
+          <p:cNvPr id="9" name="Rectangle 8"/>
+          <p:cNvSpPr/>
+          <p:nvPr/>
+        </p:nvSpPr>
+        <p:spPr>
+          <a:xfrm>
+            <a:off x="457200" y="2478024"/>
+            <a:ext cx="128016" cy="1051560"/>
+          </a:xfrm>
+          <a:prstGeom prst="rect">
+            <a:avLst/>
+          </a:prstGeom>
+          <a:solidFill>
+            <a:srgbClr val="FFD000"/>
+          </a:solidFill>
+          <a:ln>
+            <a:noFill/>
+          </a:ln>
+        </p:spPr>
+        <p:style>
+          <a:lnRef idx="1">
+            <a:schemeClr val="accent1"/>
+          </a:lnRef>
+          <a:fillRef idx="3">
+            <a:schemeClr val="accent1"/>
+          </a:fillRef>
+          <a:effectRef idx="2">
+            <a:schemeClr val="accent1"/>
+          </a:effectRef>
+          <a:fontRef idx="minor">
+            <a:schemeClr val="lt1"/>
+          </a:fontRef>
+        </p:style>
+        <p:txBody>
+          <a:bodyPr rtlCol="0" anchor="ctr"/>
+          <a:lstStyle/>
+          <a:p>
+            <a:pPr algn="ctr"/>
+          </a:p>
+        </p:txBody>
+      </p:sp>
+      <p:sp>
+        <p:nvSpPr>
+          <p:cNvPr id="10" name="TextBox 9"/>
+          <p:cNvSpPr txBox="1"/>
+          <p:nvPr/>
+        </p:nvSpPr>
+        <p:spPr>
+          <a:xfrm>
+            <a:off x="777240" y="2615184"/>
+            <a:ext cx="10774375" cy="822959"/>
+          </a:xfrm>
+          <a:prstGeom prst="rect">
+            <a:avLst/>
+          </a:prstGeom>
+          <a:noFill/>
+        </p:spPr>
+        <p:txBody>
+          <a:bodyPr wrap="square">
+            <a:spAutoFit/>
+          </a:bodyPr>
+          <a:lstStyle/>
+          <a:p>
+            <a:r>
+              <a:rPr sz="1200" b="1" i="0">
+                <a:solidFill>
+                  <a:srgbClr val="FFD000"/>
+                </a:solidFill>
+                <a:latin typeface="Calibri"/>
+              </a:rPr>
+              <a:t>Aclaración</a:t>
+            </a:r>
+          </a:p>
+          <a:p>
+            <a:pPr>
+              <a:spcBef>
+                <a:spcPts val="400"/>
+              </a:spcBef>
+            </a:pPr>
+            <a:r>
+              <a:rPr sz="1400" b="0" i="0">
+                <a:solidFill>
+                  <a:srgbClr val="333333"/>
+                </a:solidFill>
+                <a:latin typeface="Calibri"/>
+              </a:rPr>
+              <a:t>Subir evidencias al paquete CloudLite (Drive/repo) y a la plataforma del curso en la fecha que indique el docente.</a:t>
+            </a:r>
+          </a:p>
+        </p:txBody>
+      </p:sp>
+      <p:sp>
+        <p:nvSpPr>
+          <p:cNvPr id="11" name="Rounded Rectangle 10"/>
+          <p:cNvSpPr/>
+          <p:nvPr/>
+        </p:nvSpPr>
+        <p:spPr>
+          <a:xfrm>
+            <a:off x="457200" y="3694176"/>
+            <a:ext cx="11277295" cy="1051560"/>
+          </a:xfrm>
+          <a:prstGeom prst="roundRect">
+            <a:avLst>
+              <a:gd name="adj" fmla="val 12000"/>
+            </a:avLst>
+          </a:prstGeom>
+          <a:solidFill>
+            <a:srgbClr val="FBE4E4"/>
+          </a:solidFill>
+          <a:ln>
+            <a:noFill/>
+          </a:ln>
+        </p:spPr>
+        <p:style>
+          <a:lnRef idx="1">
+            <a:schemeClr val="accent1"/>
+          </a:lnRef>
+          <a:fillRef idx="3">
+            <a:schemeClr val="accent1"/>
+          </a:fillRef>
+          <a:effectRef idx="2">
+            <a:schemeClr val="accent1"/>
+          </a:effectRef>
+          <a:fontRef idx="minor">
+            <a:schemeClr val="lt1"/>
+          </a:fontRef>
+        </p:style>
+        <p:txBody>
+          <a:bodyPr rtlCol="0" anchor="ctr"/>
+          <a:lstStyle/>
+          <a:p>
+            <a:pPr algn="ctr"/>
+          </a:p>
+        </p:txBody>
+      </p:sp>
+      <p:sp>
+        <p:nvSpPr>
+          <p:cNvPr id="12" name="Rectangle 11"/>
+          <p:cNvSpPr/>
+          <p:nvPr/>
+        </p:nvSpPr>
+        <p:spPr>
+          <a:xfrm>
+            <a:off x="457200" y="3694176"/>
+            <a:ext cx="128016" cy="1051560"/>
+          </a:xfrm>
+          <a:prstGeom prst="rect">
+            <a:avLst/>
+          </a:prstGeom>
+          <a:solidFill>
+            <a:srgbClr val="A02030"/>
+          </a:solidFill>
+          <a:ln>
+            <a:noFill/>
+          </a:ln>
+        </p:spPr>
+        <p:style>
+          <a:lnRef idx="1">
+            <a:schemeClr val="accent1"/>
+          </a:lnRef>
+          <a:fillRef idx="3">
+            <a:schemeClr val="accent1"/>
+          </a:fillRef>
+          <a:effectRef idx="2">
+            <a:schemeClr val="accent1"/>
+          </a:effectRef>
+          <a:fontRef idx="minor">
+            <a:schemeClr val="lt1"/>
+          </a:fontRef>
+        </p:style>
+        <p:txBody>
+          <a:bodyPr rtlCol="0" anchor="ctr"/>
+          <a:lstStyle/>
+          <a:p>
+            <a:pPr algn="ctr"/>
+          </a:p>
+        </p:txBody>
+      </p:sp>
+      <p:sp>
+        <p:nvSpPr>
+          <p:cNvPr id="13" name="TextBox 12"/>
+          <p:cNvSpPr txBox="1"/>
+          <p:nvPr/>
+        </p:nvSpPr>
+        <p:spPr>
+          <a:xfrm>
+            <a:off x="777240" y="3831336"/>
+            <a:ext cx="10774375" cy="822959"/>
+          </a:xfrm>
+          <a:prstGeom prst="rect">
+            <a:avLst/>
+          </a:prstGeom>
+          <a:noFill/>
+        </p:spPr>
+        <p:txBody>
+          <a:bodyPr wrap="square">
+            <a:spAutoFit/>
+          </a:bodyPr>
+          <a:lstStyle/>
+          <a:p>
+            <a:r>
+              <a:rPr sz="1200" b="1" i="0">
+                <a:solidFill>
+                  <a:srgbClr val="A02030"/>
+                </a:solidFill>
+                <a:latin typeface="Calibri"/>
+              </a:rPr>
+              <a:t>Atención</a:t>
+            </a:r>
+          </a:p>
+          <a:p>
+            <a:pPr>
+              <a:spcBef>
+                <a:spcPts val="400"/>
+              </a:spcBef>
+            </a:pPr>
+            <a:r>
+              <a:rPr sz="1400" b="0" i="0">
+                <a:solidFill>
+                  <a:srgbClr val="333333"/>
+                </a:solidFill>
+                <a:latin typeface="Calibri"/>
+              </a:rPr>
+              <a:t>Sin cloud de pago ni instalaciones obligatorias de hipervisores/Docker Desktop.</a:t>
+            </a:r>
+          </a:p>
+        </p:txBody>
+      </p:sp>
+      <p:sp>
+        <p:nvSpPr>
+          <p:cNvPr id="14" name="TextBox 13"/>
+          <p:cNvSpPr txBox="1"/>
+          <p:nvPr/>
+        </p:nvSpPr>
+        <p:spPr>
+          <a:xfrm>
+            <a:off x="11185855" y="6473952"/>
+            <a:ext cx="640080" cy="274320"/>
+          </a:xfrm>
+          <a:prstGeom prst="rect">
+            <a:avLst/>
+          </a:prstGeom>
+          <a:noFill/>
+        </p:spPr>
+        <p:txBody>
+          <a:bodyPr wrap="square">
+            <a:spAutoFit/>
+          </a:bodyPr>
+          <a:lstStyle/>
+          <a:p>
+            <a:pPr algn="r"/>
+            <a:r>
+              <a:rPr sz="1100" b="0" i="0">
+                <a:solidFill>
+                  <a:srgbClr val="666666"/>
+                </a:solidFill>
+                <a:latin typeface="Calibri"/>
+              </a:rPr>
+              <a:t>13</a:t>
+            </a:r>
+          </a:p>
+        </p:txBody>
+      </p:sp>
+    </p:spTree>
+  </p:cSld>
+  <p:clrMapOvr>
+    <a:masterClrMapping/>
+  </p:clrMapOvr>
+</p:sld>
+</file>
+
+<file path=ppt/slides/slide14.xml><?xml version="1.0" encoding="utf-8"?>
+<p:sld xmlns:a="http://schemas.openxmlformats.org/drawingml/2006/main" xmlns:p="http://schemas.openxmlformats.org/presentationml/2006/main" xmlns:r="http://schemas.openxmlformats.org/officeDocument/2006/relationships">
+  <p:cSld>
+    <p:bg>
+      <p:bgPr>
+        <a:solidFill>
+          <a:srgbClr val="FFFFFF"/>
+        </a:solidFill>
+        <a:effectLst/>
+      </p:bgPr>
+    </p:bg>
+    <p:spTree>
+      <p:nvGrpSpPr>
+        <p:cNvPr id="1" name=""/>
+        <p:cNvGrpSpPr/>
+        <p:nvPr/>
+      </p:nvGrpSpPr>
+      <p:grpSpPr/>
+      <p:sp>
+        <p:nvSpPr>
+          <p:cNvPr id="2" name="Rectangle 1"/>
+          <p:cNvSpPr/>
+          <p:nvPr/>
+        </p:nvSpPr>
+        <p:spPr>
+          <a:xfrm>
+            <a:off x="0" y="0"/>
             <a:ext cx="12191695" cy="164592"/>
           </a:xfrm>
           <a:prstGeom prst="rect">
@@ -5677,7 +5991,7 @@
                 </a:solidFill>
                 <a:latin typeface="Calibri"/>
               </a:rPr>
-              <a:t> Taller guiado PI (demo en vivo + avance individual).</a:t>
+              <a:t> Trabajo guiado del PI (demo en vivo + avance individual).</a:t>
             </a:r>
           </a:p>
           <a:p>
@@ -6196,7 +6510,7 @@
                 </a:solidFill>
                 <a:latin typeface="Calibri"/>
               </a:rPr>
-              <a:t>PI CloudLite — entregable de hoy</a:t>
+              <a:t>IaaS · PaaS · SaaS (sin cloud de pago)</a:t>
             </a:r>
           </a:p>
         </p:txBody>
@@ -6244,7 +6558,7 @@
                 </a:solidFill>
                 <a:latin typeface="Calibri"/>
               </a:rPr>
-              <a:t>Entregable:</a:t>
+              <a:t>IaaS</a:t>
             </a:r>
             <a:r>
               <a:rPr sz="2000" b="0" i="0">
@@ -6253,7 +6567,7 @@
                 </a:solidFill>
                 <a:latin typeface="Calibri"/>
               </a:rPr>
-              <a:t> ADR-001: decisión de modelo de servicio + matriz de comparación aplicada al dominio</a:t>
+              <a:t>: usted administra SO/red/runtime; el proveedor da cómputo/red/disco.</a:t>
             </a:r>
           </a:p>
           <a:p>
@@ -6269,7 +6583,7 @@
                 </a:solidFill>
                 <a:latin typeface="Calibri"/>
               </a:rPr>
-              <a:t>–   Herramienta: </a:t>
+              <a:t>–   </a:t>
             </a:r>
             <a:r>
               <a:rPr sz="2000" b="1" i="0">
@@ -6278,7 +6592,16 @@
                 </a:solidFill>
                 <a:latin typeface="Calibri"/>
               </a:rPr>
-              <a:t>Google Docs · draw.io (opcional)</a:t>
+              <a:t>PaaS</a:t>
+            </a:r>
+            <a:r>
+              <a:rPr sz="2000" b="0" i="0">
+                <a:solidFill>
+                  <a:srgbClr val="333333"/>
+                </a:solidFill>
+                <a:latin typeface="Calibri"/>
+              </a:rPr>
+              <a:t>: usted despliega app; el proveedor gestiona runtime/escala básica.</a:t>
             </a:r>
           </a:p>
           <a:p>
@@ -6294,7 +6617,7 @@
                 </a:solidFill>
                 <a:latin typeface="Calibri"/>
               </a:rPr>
-              <a:t>–   Todo lo que construyan hoy entra al </a:t>
+              <a:t>–   </a:t>
             </a:r>
             <a:r>
               <a:rPr sz="2000" b="1" i="0">
@@ -6303,7 +6626,7 @@
                 </a:solidFill>
                 <a:latin typeface="Calibri"/>
               </a:rPr>
-              <a:t>informe/repo del PI</a:t>
+              <a:t>SaaS</a:t>
             </a:r>
             <a:r>
               <a:rPr sz="2000" b="0" i="0">
@@ -6312,7 +6635,7 @@
                 </a:solidFill>
                 <a:latin typeface="Calibri"/>
               </a:rPr>
-              <a:t> (no es lab suelto).</a:t>
+              <a:t>: consume el servicio listo (correo, CRM); poca personalización profunda.</a:t>
             </a:r>
           </a:p>
           <a:p>
@@ -6328,7 +6651,25 @@
                 </a:solidFill>
                 <a:latin typeface="Calibri"/>
               </a:rPr>
-              <a:t>–   Individual por defecto · el docente puede autorizar equipos de 2–3; la entrega en la plataforma del curso siempre es individual.</a:t>
+              <a:t>–   En este curso </a:t>
+            </a:r>
+            <a:r>
+              <a:rPr sz="2000" b="1" i="0">
+                <a:solidFill>
+                  <a:srgbClr val="333333"/>
+                </a:solidFill>
+                <a:latin typeface="Calibri"/>
+              </a:rPr>
+              <a:t>simulamos</a:t>
+            </a:r>
+            <a:r>
+              <a:rPr sz="2000" b="0" i="0">
+                <a:solidFill>
+                  <a:srgbClr val="333333"/>
+                </a:solidFill>
+                <a:latin typeface="Calibri"/>
+              </a:rPr>
+              <a:t> con labs/navegador; no abrimos cuentas IaaS con tarjeta.</a:t>
             </a:r>
           </a:p>
         </p:txBody>
@@ -6509,7 +6850,7 @@
                 </a:solidFill>
                 <a:latin typeface="Calibri"/>
               </a:rPr>
-              <a:t>IaaS · PaaS · SaaS (sin cloud de pago)</a:t>
+              <a:t>Cómo decidir para CloudLite</a:t>
             </a:r>
           </a:p>
         </p:txBody>
@@ -6548,25 +6889,7 @@
                 </a:solidFill>
                 <a:latin typeface="Calibri"/>
               </a:rPr>
-              <a:t>–   </a:t>
-            </a:r>
-            <a:r>
-              <a:rPr sz="2000" b="1" i="0">
-                <a:solidFill>
-                  <a:srgbClr val="333333"/>
-                </a:solidFill>
-                <a:latin typeface="Calibri"/>
-              </a:rPr>
-              <a:t>IaaS</a:t>
-            </a:r>
-            <a:r>
-              <a:rPr sz="2000" b="0" i="0">
-                <a:solidFill>
-                  <a:srgbClr val="333333"/>
-                </a:solidFill>
-                <a:latin typeface="Calibri"/>
-              </a:rPr>
-              <a:t>: usted administra SO/red/runtime; el proveedor da cómputo/red/disco.</a:t>
+              <a:t>–   Pregunte: ¿necesito controlar red/SO o solo desplegar API+datos?</a:t>
             </a:r>
           </a:p>
           <a:p>
@@ -6582,7 +6905,7 @@
                 </a:solidFill>
                 <a:latin typeface="Calibri"/>
               </a:rPr>
-              <a:t>–   </a:t>
+              <a:t>–   Para un MVP académico suele ganar </a:t>
             </a:r>
             <a:r>
               <a:rPr sz="2000" b="1" i="0">
@@ -6591,7 +6914,7 @@
                 </a:solidFill>
                 <a:latin typeface="Calibri"/>
               </a:rPr>
-              <a:t>PaaS</a:t>
+              <a:t>PaaS conceptual</a:t>
             </a:r>
             <a:r>
               <a:rPr sz="2000" b="0" i="0">
@@ -6600,7 +6923,7 @@
                 </a:solidFill>
                 <a:latin typeface="Calibri"/>
               </a:rPr>
-              <a:t>: usted despliega app; el proveedor gestiona runtime/escala básica.</a:t>
+              <a:t> + contenedores (portable).</a:t>
             </a:r>
           </a:p>
           <a:p>
@@ -6616,25 +6939,7 @@
                 </a:solidFill>
                 <a:latin typeface="Calibri"/>
               </a:rPr>
-              <a:t>–   </a:t>
-            </a:r>
-            <a:r>
-              <a:rPr sz="2000" b="1" i="0">
-                <a:solidFill>
-                  <a:srgbClr val="333333"/>
-                </a:solidFill>
-                <a:latin typeface="Calibri"/>
-              </a:rPr>
-              <a:t>SaaS</a:t>
-            </a:r>
-            <a:r>
-              <a:rPr sz="2000" b="0" i="0">
-                <a:solidFill>
-                  <a:srgbClr val="333333"/>
-                </a:solidFill>
-                <a:latin typeface="Calibri"/>
-              </a:rPr>
-              <a:t>: consume el servicio listo (correo, CRM); poca personalización profunda.</a:t>
+              <a:t>–   Si el dominio exige mucho control de red → justifique IaaS *simulado* en diagrama.</a:t>
             </a:r>
           </a:p>
           <a:p>
@@ -6650,7 +6955,7 @@
                 </a:solidFill>
                 <a:latin typeface="Calibri"/>
               </a:rPr>
-              <a:t>–   En este curso </a:t>
+              <a:t>–   SaaS solo como </a:t>
             </a:r>
             <a:r>
               <a:rPr sz="2000" b="1" i="0">
@@ -6659,7 +6964,7 @@
                 </a:solidFill>
                 <a:latin typeface="Calibri"/>
               </a:rPr>
-              <a:t>simulamos</a:t>
+              <a:t>satélite</a:t>
             </a:r>
             <a:r>
               <a:rPr sz="2000" b="0" i="0">
@@ -6668,7 +6973,7 @@
                 </a:solidFill>
                 <a:latin typeface="Calibri"/>
               </a:rPr>
-              <a:t> con labs/navegador; no abrimos cuentas IaaS con tarjeta.</a:t>
+              <a:t> (auth, email, analytics) — no como toda la app.</a:t>
             </a:r>
           </a:p>
         </p:txBody>
@@ -6849,7 +7154,7 @@
                 </a:solidFill>
                 <a:latin typeface="Calibri"/>
               </a:rPr>
-              <a:t>Cómo decidir para CloudLite</a:t>
+              <a:t>Responsabilidad compartida: quién responde por qué</a:t>
             </a:r>
           </a:p>
         </p:txBody>
@@ -6888,7 +7193,61 @@
                 </a:solidFill>
                 <a:latin typeface="Calibri"/>
               </a:rPr>
-              <a:t>–   Pregunte: ¿necesito controlar red/SO o solo desplegar API+datos?</a:t>
+              <a:t>–   </a:t>
+            </a:r>
+            <a:r>
+              <a:rPr sz="2000" b="1" i="0">
+                <a:solidFill>
+                  <a:srgbClr val="333333"/>
+                </a:solidFill>
+                <a:latin typeface="Calibri"/>
+              </a:rPr>
+              <a:t>Regla que hay que memorizar:</a:t>
+            </a:r>
+            <a:r>
+              <a:rPr sz="2000" b="0" i="0">
+                <a:solidFill>
+                  <a:srgbClr val="333333"/>
+                </a:solidFill>
+                <a:latin typeface="Calibri"/>
+              </a:rPr>
+              <a:t> el proveedor responde por la seguridad </a:t>
+            </a:r>
+            <a:r>
+              <a:rPr sz="2000" b="1" i="0">
+                <a:solidFill>
+                  <a:srgbClr val="333333"/>
+                </a:solidFill>
+                <a:latin typeface="Calibri"/>
+              </a:rPr>
+              <a:t>DE</a:t>
+            </a:r>
+            <a:r>
+              <a:rPr sz="2000" b="0" i="0">
+                <a:solidFill>
+                  <a:srgbClr val="333333"/>
+                </a:solidFill>
+                <a:latin typeface="Calibri"/>
+              </a:rPr>
+              <a:t> la nube (centro de datos, hipervisor, cifrado en reposo); usted responde por la seguridad </a:t>
+            </a:r>
+            <a:r>
+              <a:rPr sz="2000" b="1" i="0">
+                <a:solidFill>
+                  <a:srgbClr val="333333"/>
+                </a:solidFill>
+                <a:latin typeface="Calibri"/>
+              </a:rPr>
+              <a:t>EN</a:t>
+            </a:r>
+            <a:r>
+              <a:rPr sz="2000" b="0" i="0">
+                <a:solidFill>
+                  <a:srgbClr val="333333"/>
+                </a:solidFill>
+                <a:latin typeface="Calibri"/>
+              </a:rPr>
+              <a:t> la nube (contraseñas, permisos, datos, configuración).</a:t>
             </a:r>
           </a:p>
           <a:p>
@@ -6904,7 +7263,7 @@
                 </a:solidFill>
                 <a:latin typeface="Calibri"/>
               </a:rPr>
-              <a:t>–   Para un MVP académico suele ganar </a:t>
+              <a:t>–   La causa dominante de incidentes en la nube </a:t>
             </a:r>
             <a:r>
               <a:rPr sz="2000" b="1" i="0">
@@ -6913,7 +7272,7 @@
                 </a:solidFill>
                 <a:latin typeface="Calibri"/>
               </a:rPr>
-              <a:t>PaaS conceptual</a:t>
+              <a:t>no</a:t>
             </a:r>
             <a:r>
               <a:rPr sz="2000" b="0" i="0">
@@ -6922,7 +7281,7 @@
                 </a:solidFill>
                 <a:latin typeface="Calibri"/>
               </a:rPr>
-              <a:t> + contenedores (portable).</a:t>
+              <a:t> es una falla del proveedor: es una configuración del cliente (un bucket público, una credencial en el repo, un puerto de base de datos expuesto).</a:t>
             </a:r>
           </a:p>
           <a:p>
@@ -6938,7 +7297,79 @@
                 </a:solidFill>
                 <a:latin typeface="Calibri"/>
               </a:rPr>
-              <a:t>–   Si el dominio exige mucho control de red → justifique IaaS *simulado* en diagrama.</a:t>
+              <a:t>–   </a:t>
+            </a:r>
+            <a:r>
+              <a:rPr sz="2000" b="1" i="0">
+                <a:solidFill>
+                  <a:srgbClr val="333333"/>
+                </a:solidFill>
+                <a:latin typeface="Calibri"/>
+              </a:rPr>
+              <a:t>Vendor lock-in</a:t>
+            </a:r>
+            <a:r>
+              <a:rPr sz="2000" b="0" i="0">
+                <a:solidFill>
+                  <a:srgbClr val="333333"/>
+                </a:solidFill>
+                <a:latin typeface="Calibri"/>
+              </a:rPr>
+              <a:t> (costo de mudarse de proveedor): </a:t>
+            </a:r>
+            <a:r>
+              <a:rPr sz="2000" b="1" i="0">
+                <a:solidFill>
+                  <a:srgbClr val="333333"/>
+                </a:solidFill>
+                <a:latin typeface="Calibri"/>
+              </a:rPr>
+              <a:t>bajo</a:t>
+            </a:r>
+            <a:r>
+              <a:rPr sz="2000" b="0" i="0">
+                <a:solidFill>
+                  <a:srgbClr val="333333"/>
+                </a:solidFill>
+                <a:latin typeface="Calibri"/>
+              </a:rPr>
+              <a:t> en IaaS (una VM Linux se parece a cualquier otra) · </a:t>
+            </a:r>
+            <a:r>
+              <a:rPr sz="2000" b="1" i="0">
+                <a:solidFill>
+                  <a:srgbClr val="333333"/>
+                </a:solidFill>
+                <a:latin typeface="Calibri"/>
+              </a:rPr>
+              <a:t>medio</a:t>
+            </a:r>
+            <a:r>
+              <a:rPr sz="2000" b="0" i="0">
+                <a:solidFill>
+                  <a:srgbClr val="333333"/>
+                </a:solidFill>
+                <a:latin typeface="Calibri"/>
+              </a:rPr>
+              <a:t> en PaaS (el archivo de configuración y algún servicio son propietarios) · </a:t>
+            </a:r>
+            <a:r>
+              <a:rPr sz="2000" b="1" i="0">
+                <a:solidFill>
+                  <a:srgbClr val="333333"/>
+                </a:solidFill>
+                <a:latin typeface="Calibri"/>
+              </a:rPr>
+              <a:t>potencialmente alto</a:t>
+            </a:r>
+            <a:r>
+              <a:rPr sz="2000" b="0" i="0">
+                <a:solidFill>
+                  <a:srgbClr val="333333"/>
+                </a:solidFill>
+                <a:latin typeface="Calibri"/>
+              </a:rPr>
+              <a:t> en SaaS (datos y lógica viven dentro del producto ajeno).</a:t>
             </a:r>
           </a:p>
           <a:p>
@@ -6954,7 +7385,7 @@
                 </a:solidFill>
                 <a:latin typeface="Calibri"/>
               </a:rPr>
-              <a:t>–   SaaS solo como </a:t>
+              <a:t>–   Mitigación para CloudLite: no evitar SaaS, </a:t>
             </a:r>
             <a:r>
               <a:rPr sz="2000" b="1" i="0">
@@ -6963,7 +7394,7 @@
                 </a:solidFill>
                 <a:latin typeface="Calibri"/>
               </a:rPr>
-              <a:t>satélite</a:t>
+              <a:t>acotarlo</a:t>
             </a:r>
             <a:r>
               <a:rPr sz="2000" b="0" i="0">
@@ -6972,7 +7403,7 @@
                 </a:solidFill>
                 <a:latin typeface="Calibri"/>
               </a:rPr>
-              <a:t> (auth, email, analytics) — no como toda la app.</a:t>
+              <a:t> — si el envío de correos vive detrás de una interfaz propia («Notificador.enviar()»), cambiar de proveedor toca un archivo, no cuarenta.</a:t>
             </a:r>
           </a:p>
         </p:txBody>

</xml_diff>